<commit_message>
Update GenAI Product Canvas template with latest visual revisions
</commit_message>
<xml_diff>
--- a/agentic-workloads/genai-product-canvas/genai-product-canvas-template.pptx
+++ b/agentic-workloads/genai-product-canvas/genai-product-canvas-template.pptx
@@ -302,7 +302,7 @@
           <a:p>
             <a:fld id="{5BCAD085-E8A6-8845-BD4E-CB4CCA059FC4}" type="datetimeFigureOut">
               <a:rPr lang="en-US" smtClean="0"/>
-              <a:t>6/22/26</a:t>
+              <a:t>6/25/26</a:t>
             </a:fld>
             <a:endParaRPr lang="en-US"/>
           </a:p>
@@ -470,7 +470,7 @@
           <a:p>
             <a:fld id="{5BCAD085-E8A6-8845-BD4E-CB4CCA059FC4}" type="datetimeFigureOut">
               <a:rPr lang="en-US" smtClean="0"/>
-              <a:t>6/22/26</a:t>
+              <a:t>6/25/26</a:t>
             </a:fld>
             <a:endParaRPr lang="en-US"/>
           </a:p>
@@ -648,7 +648,7 @@
           <a:p>
             <a:fld id="{5BCAD085-E8A6-8845-BD4E-CB4CCA059FC4}" type="datetimeFigureOut">
               <a:rPr lang="en-US" smtClean="0"/>
-              <a:t>6/22/26</a:t>
+              <a:t>6/25/26</a:t>
             </a:fld>
             <a:endParaRPr lang="en-US"/>
           </a:p>
@@ -816,7 +816,7 @@
           <a:p>
             <a:fld id="{5BCAD085-E8A6-8845-BD4E-CB4CCA059FC4}" type="datetimeFigureOut">
               <a:rPr lang="en-US" smtClean="0"/>
-              <a:t>6/22/26</a:t>
+              <a:t>6/25/26</a:t>
             </a:fld>
             <a:endParaRPr lang="en-US"/>
           </a:p>
@@ -1061,7 +1061,7 @@
           <a:p>
             <a:fld id="{5BCAD085-E8A6-8845-BD4E-CB4CCA059FC4}" type="datetimeFigureOut">
               <a:rPr lang="en-US" smtClean="0"/>
-              <a:t>6/22/26</a:t>
+              <a:t>6/25/26</a:t>
             </a:fld>
             <a:endParaRPr lang="en-US"/>
           </a:p>
@@ -1346,7 +1346,7 @@
           <a:p>
             <a:fld id="{5BCAD085-E8A6-8845-BD4E-CB4CCA059FC4}" type="datetimeFigureOut">
               <a:rPr lang="en-US" smtClean="0"/>
-              <a:t>6/22/26</a:t>
+              <a:t>6/25/26</a:t>
             </a:fld>
             <a:endParaRPr lang="en-US"/>
           </a:p>
@@ -1765,7 +1765,7 @@
           <a:p>
             <a:fld id="{5BCAD085-E8A6-8845-BD4E-CB4CCA059FC4}" type="datetimeFigureOut">
               <a:rPr lang="en-US" smtClean="0"/>
-              <a:t>6/22/26</a:t>
+              <a:t>6/25/26</a:t>
             </a:fld>
             <a:endParaRPr lang="en-US"/>
           </a:p>
@@ -1882,7 +1882,7 @@
           <a:p>
             <a:fld id="{5BCAD085-E8A6-8845-BD4E-CB4CCA059FC4}" type="datetimeFigureOut">
               <a:rPr lang="en-US" smtClean="0"/>
-              <a:t>6/22/26</a:t>
+              <a:t>6/25/26</a:t>
             </a:fld>
             <a:endParaRPr lang="en-US"/>
           </a:p>
@@ -1977,7 +1977,7 @@
           <a:p>
             <a:fld id="{5BCAD085-E8A6-8845-BD4E-CB4CCA059FC4}" type="datetimeFigureOut">
               <a:rPr lang="en-US" smtClean="0"/>
-              <a:t>6/22/26</a:t>
+              <a:t>6/25/26</a:t>
             </a:fld>
             <a:endParaRPr lang="en-US"/>
           </a:p>
@@ -2252,7 +2252,7 @@
           <a:p>
             <a:fld id="{5BCAD085-E8A6-8845-BD4E-CB4CCA059FC4}" type="datetimeFigureOut">
               <a:rPr lang="en-US" smtClean="0"/>
-              <a:t>6/22/26</a:t>
+              <a:t>6/25/26</a:t>
             </a:fld>
             <a:endParaRPr lang="en-US"/>
           </a:p>
@@ -2504,7 +2504,7 @@
           <a:p>
             <a:fld id="{5BCAD085-E8A6-8845-BD4E-CB4CCA059FC4}" type="datetimeFigureOut">
               <a:rPr lang="en-US" smtClean="0"/>
-              <a:t>6/22/26</a:t>
+              <a:t>6/25/26</a:t>
             </a:fld>
             <a:endParaRPr lang="en-US"/>
           </a:p>
@@ -2715,7 +2715,7 @@
           <a:p>
             <a:fld id="{5BCAD085-E8A6-8845-BD4E-CB4CCA059FC4}" type="datetimeFigureOut">
               <a:rPr lang="en-US" smtClean="0"/>
-              <a:t>6/22/26</a:t>
+              <a:t>6/25/26</a:t>
             </a:fld>
             <a:endParaRPr lang="en-US"/>
           </a:p>
@@ -4544,7 +4544,7 @@
         </p:nvGrpSpPr>
         <p:grpSpPr>
           <a:xfrm>
-            <a:off x="8882024" y="7465930"/>
+            <a:off x="8883821" y="4208941"/>
             <a:ext cx="6119284" cy="3138585"/>
             <a:chOff x="8514826" y="8129015"/>
             <a:chExt cx="6206352" cy="2286000"/>
@@ -5205,7 +5205,7 @@
         </p:nvGrpSpPr>
         <p:grpSpPr>
           <a:xfrm>
-            <a:off x="8889479" y="4214827"/>
+            <a:off x="8883821" y="7470526"/>
             <a:ext cx="3024000" cy="3146400"/>
             <a:chOff x="2806298" y="8108532"/>
             <a:chExt cx="2460858" cy="3654125"/>
@@ -5382,7 +5382,7 @@
         </p:nvGrpSpPr>
         <p:grpSpPr>
           <a:xfrm>
-            <a:off x="11988008" y="4214827"/>
+            <a:off x="11982350" y="7470526"/>
             <a:ext cx="3024000" cy="3146400"/>
             <a:chOff x="2806298" y="8108532"/>
             <a:chExt cx="2460858" cy="3654125"/>

</xml_diff>